<commit_message>
Aula 3: introduz a ponte Aula 2 -> it.todo e a falta de linha de base
</commit_message>
<xml_diff>
--- a/slides/aula-03-requisitos-historias-usuario.pptx
+++ b/slides/aula-03-requisitos-historias-usuario.pptx
@@ -13555,7 +13555,7 @@
                 <a:ea typeface="Calibri" pitchFamily="34" charset="-122"/>
                 <a:cs typeface="Calibri" pitchFamily="34" charset="-120"/>
               </a:rPr>
-              <a:t>O repositório sobe e o CI está verde — mas as regras de negócio são stubs que lançam erro.</a:t>
+              <a:t>CI verde, mas as regras de negócio ainda são stubs que lançam erro.</a:t>
             </a:r>
             <a:endParaRPr lang="en-US" sz="1600" dirty="0"/>
           </a:p>
@@ -13576,7 +13576,7 @@
                 <a:ea typeface="Calibri" pitchFamily="34" charset="-122"/>
                 <a:cs typeface="Calibri" pitchFamily="34" charset="-120"/>
               </a:rPr>
-              <a:t>tests/doacoes.test.js tem cinco it.todo esperando: são os critérios da história zero.</a:t>
+              <a:t>tests/doacoes.test.js tem cinco it.todo — os critérios da história zero. Um deles já é a regra que a Aula 2 classificou.</a:t>
             </a:r>
             <a:endParaRPr lang="en-US" sz="1600" dirty="0"/>
           </a:p>

</xml_diff>